<commit_message>
Actualizar presentaciones de Fase 1 al modelo de tres roles
</commit_message>
<xml_diff>
--- a/Fase 1/Evidencias Adicionales/Fase1RecyTrack.pptx
+++ b/Fase 1/Evidencias Adicionales/Fase1RecyTrack.pptx
@@ -3102,7 +3102,7 @@
                 <a:ea typeface="Calibri" pitchFamily="34" charset="-122"/>
                 <a:cs typeface="Calibri" pitchFamily="34" charset="-120"/>
               </a:rPr>
-              <a:t>Gestor</a:t>
+              <a:t>Administrador</a:t>
             </a:r>
             <a:endParaRPr lang="en-US" sz="1100" dirty="0"/>
           </a:p>
@@ -3229,7 +3229,7 @@
                 <a:ea typeface="Calibri" pitchFamily="34" charset="-122"/>
                 <a:cs typeface="Calibri" pitchFamily="34" charset="-120"/>
               </a:rPr>
-              <a:t>Reporte en el panel</a:t>
+              <a:t>Reporte y certificados</a:t>
             </a:r>
             <a:endParaRPr lang="en-US" sz="1300" dirty="0"/>
           </a:p>
@@ -3268,7 +3268,7 @@
                 <a:ea typeface="Calibri" pitchFamily="34" charset="-122"/>
                 <a:cs typeface="Calibri" pitchFamily="34" charset="-120"/>
               </a:rPr>
-              <a:t>Administrador</a:t>
+              <a:t>Sistema</a:t>
             </a:r>
             <a:endParaRPr lang="en-US" sz="1100" dirty="0"/>
           </a:p>
@@ -7286,7 +7286,7 @@
                 <a:ea typeface="Calibri" pitchFamily="34" charset="-122"/>
                 <a:cs typeface="Calibri" pitchFamily="34" charset="-120"/>
               </a:rPr>
-              <a:t>App en el celular (colaborador, validador, gestor) y panel web del administrador · app web instalable</a:t>
+              <a:t>App en el celular (colaborador y validador) y panel web del administrador, que registra los retiros · app web instalable</a:t>
             </a:r>
             <a:endParaRPr lang="en-US" sz="1100" dirty="0"/>
           </a:p>
@@ -8388,7 +8388,7 @@
                 <a:ea typeface="Calibri" pitchFamily="34" charset="-122"/>
                 <a:cs typeface="Calibri" pitchFamily="34" charset="-120"/>
               </a:rPr>
-              <a:t>Colaborador · Validador · Gestor · Panel web del administrador</a:t>
+              <a:t>Colaborador · Validador · Panel web del administrador</a:t>
             </a:r>
             <a:endParaRPr lang="en-US" sz="1200" dirty="0"/>
           </a:p>

</xml_diff>